<commit_message>
docs: add umee kintone revenue and wholesale slides
</commit_message>
<xml_diff>
--- a/deck-system/decks/umee-sbcs-kintone-plan-3980/exports/umee-sbcs-kintone-plan-3980.pptx
+++ b/deck-system/decks/umee-sbcs-kintone-plan-3980/exports/umee-sbcs-kintone-plan-3980.pptx
@@ -1,6 +1,6 @@
 
 <file path=ppt/presentation.xml><?xml version="1.0" encoding="utf-8"?>
-<p:presentation xmlns:a="http://schemas.openxmlformats.org/drawingml/2006/main" xmlns:r="http://schemas.openxmlformats.org/officeDocument/2006/relationships" xmlns:p="http://schemas.openxmlformats.org/presentationml/2006/main" saveSubsetFonts="1">
+<p:presentation xmlns:a="http://schemas.openxmlformats.org/drawingml/2006/main" xmlns:r="http://schemas.openxmlformats.org/officeDocument/2006/relationships" xmlns:p="http://schemas.openxmlformats.org/presentationml/2006/main">
   <p:sldMasterIdLst>
     <p:sldMasterId id="2147483648" r:id="rId1"/>
   </p:sldMasterIdLst>
@@ -16,14 +16,13 @@
     <p:sldId id="264" r:id="rId10"/>
     <p:sldId id="265" r:id="rId11"/>
     <p:sldId id="266" r:id="rId12"/>
+    <p:sldId id="267" r:id="rId13"/>
+    <p:sldId id="268" r:id="rId14"/>
+    <p:sldId id="269" r:id="rId15"/>
+    <p:sldId id="270" r:id="rId16"/>
   </p:sldIdLst>
   <p:sldSz cx="12192000" cy="6858000" type="wide"/>
   <p:notesSz cx="6858000" cy="9144000"/>
-  <p:defaultTextStyle>
-    <a:defPPr>
-      <a:defRPr lang="ja-JP"/>
-    </a:defPPr>
-  </p:defaultTextStyle>
 </p:presentation>
 </file>
 
@@ -102,14 +101,12 @@
       </p:grpSpPr>
       <p:pic>
         <p:nvPicPr>
-          <p:cNvPr id="2" name="Slide 1 image"/>
-          <p:cNvPicPr>
-            <a:picLocks noChangeAspect="1"/>
-          </p:cNvPicPr>
-          <p:nvPr/>
-        </p:nvPicPr>
-        <p:blipFill>
-          <a:blip r:embed="rId2"/>
+          <p:cNvPr id="2" name="slide-1.png"/>
+          <p:cNvPicPr/>
+          <p:nvPr/>
+        </p:nvPicPr>
+        <p:blipFill>
+          <a:blip r:embed="rId1"/>
           <a:stretch>
             <a:fillRect/>
           </a:stretch>
@@ -151,14 +148,12 @@
       </p:grpSpPr>
       <p:pic>
         <p:nvPicPr>
-          <p:cNvPr id="2" name="Slide 10 image"/>
-          <p:cNvPicPr>
-            <a:picLocks noChangeAspect="1"/>
-          </p:cNvPicPr>
-          <p:nvPr/>
-        </p:nvPicPr>
-        <p:blipFill>
-          <a:blip r:embed="rId2"/>
+          <p:cNvPr id="2" name="slide-10.png"/>
+          <p:cNvPicPr/>
+          <p:nvPr/>
+        </p:nvPicPr>
+        <p:blipFill>
+          <a:blip r:embed="rId1"/>
           <a:stretch>
             <a:fillRect/>
           </a:stretch>
@@ -200,14 +195,200 @@
       </p:grpSpPr>
       <p:pic>
         <p:nvPicPr>
-          <p:cNvPr id="2" name="Slide 11 image"/>
-          <p:cNvPicPr>
-            <a:picLocks noChangeAspect="1"/>
-          </p:cNvPicPr>
-          <p:nvPr/>
-        </p:nvPicPr>
-        <p:blipFill>
-          <a:blip r:embed="rId2"/>
+          <p:cNvPr id="2" name="slide-11.png"/>
+          <p:cNvPicPr/>
+          <p:nvPr/>
+        </p:nvPicPr>
+        <p:blipFill>
+          <a:blip r:embed="rId1"/>
+          <a:stretch>
+            <a:fillRect/>
+          </a:stretch>
+        </p:blipFill>
+        <p:spPr>
+          <a:xfrm>
+            <a:off x="0" y="0"/>
+            <a:ext cx="12192000" cy="6858000"/>
+          </a:xfrm>
+          <a:prstGeom prst="rect">
+            <a:avLst/>
+          </a:prstGeom>
+        </p:spPr>
+      </p:pic>
+    </p:spTree>
+  </p:cSld>
+  <p:clrMapOvr>
+    <a:masterClrMapping/>
+  </p:clrMapOvr>
+</p:sld>
+</file>
+
+<file path=ppt/slides/slide12.xml><?xml version="1.0" encoding="utf-8"?>
+<p:sld xmlns:a="http://schemas.openxmlformats.org/drawingml/2006/main" xmlns:r="http://schemas.openxmlformats.org/officeDocument/2006/relationships" xmlns:p="http://schemas.openxmlformats.org/presentationml/2006/main">
+  <p:cSld>
+    <p:spTree>
+      <p:nvGrpSpPr>
+        <p:cNvPr id="1" name=""/>
+        <p:cNvGrpSpPr/>
+        <p:nvPr/>
+      </p:nvGrpSpPr>
+      <p:grpSpPr>
+        <a:xfrm>
+          <a:off x="0" y="0"/>
+          <a:ext cx="0" cy="0"/>
+          <a:chOff x="0" y="0"/>
+          <a:chExt cx="0" cy="0"/>
+        </a:xfrm>
+      </p:grpSpPr>
+      <p:pic>
+        <p:nvPicPr>
+          <p:cNvPr id="2" name="slide-12.png"/>
+          <p:cNvPicPr/>
+          <p:nvPr/>
+        </p:nvPicPr>
+        <p:blipFill>
+          <a:blip r:embed="rId1"/>
+          <a:stretch>
+            <a:fillRect/>
+          </a:stretch>
+        </p:blipFill>
+        <p:spPr>
+          <a:xfrm>
+            <a:off x="0" y="0"/>
+            <a:ext cx="12192000" cy="6858000"/>
+          </a:xfrm>
+          <a:prstGeom prst="rect">
+            <a:avLst/>
+          </a:prstGeom>
+        </p:spPr>
+      </p:pic>
+    </p:spTree>
+  </p:cSld>
+  <p:clrMapOvr>
+    <a:masterClrMapping/>
+  </p:clrMapOvr>
+</p:sld>
+</file>
+
+<file path=ppt/slides/slide13.xml><?xml version="1.0" encoding="utf-8"?>
+<p:sld xmlns:a="http://schemas.openxmlformats.org/drawingml/2006/main" xmlns:r="http://schemas.openxmlformats.org/officeDocument/2006/relationships" xmlns:p="http://schemas.openxmlformats.org/presentationml/2006/main">
+  <p:cSld>
+    <p:spTree>
+      <p:nvGrpSpPr>
+        <p:cNvPr id="1" name=""/>
+        <p:cNvGrpSpPr/>
+        <p:nvPr/>
+      </p:nvGrpSpPr>
+      <p:grpSpPr>
+        <a:xfrm>
+          <a:off x="0" y="0"/>
+          <a:ext cx="0" cy="0"/>
+          <a:chOff x="0" y="0"/>
+          <a:chExt cx="0" cy="0"/>
+        </a:xfrm>
+      </p:grpSpPr>
+      <p:pic>
+        <p:nvPicPr>
+          <p:cNvPr id="2" name="slide-13.png"/>
+          <p:cNvPicPr/>
+          <p:nvPr/>
+        </p:nvPicPr>
+        <p:blipFill>
+          <a:blip r:embed="rId1"/>
+          <a:stretch>
+            <a:fillRect/>
+          </a:stretch>
+        </p:blipFill>
+        <p:spPr>
+          <a:xfrm>
+            <a:off x="0" y="0"/>
+            <a:ext cx="12192000" cy="6858000"/>
+          </a:xfrm>
+          <a:prstGeom prst="rect">
+            <a:avLst/>
+          </a:prstGeom>
+        </p:spPr>
+      </p:pic>
+    </p:spTree>
+  </p:cSld>
+  <p:clrMapOvr>
+    <a:masterClrMapping/>
+  </p:clrMapOvr>
+</p:sld>
+</file>
+
+<file path=ppt/slides/slide14.xml><?xml version="1.0" encoding="utf-8"?>
+<p:sld xmlns:a="http://schemas.openxmlformats.org/drawingml/2006/main" xmlns:r="http://schemas.openxmlformats.org/officeDocument/2006/relationships" xmlns:p="http://schemas.openxmlformats.org/presentationml/2006/main">
+  <p:cSld>
+    <p:spTree>
+      <p:nvGrpSpPr>
+        <p:cNvPr id="1" name=""/>
+        <p:cNvGrpSpPr/>
+        <p:nvPr/>
+      </p:nvGrpSpPr>
+      <p:grpSpPr>
+        <a:xfrm>
+          <a:off x="0" y="0"/>
+          <a:ext cx="0" cy="0"/>
+          <a:chOff x="0" y="0"/>
+          <a:chExt cx="0" cy="0"/>
+        </a:xfrm>
+      </p:grpSpPr>
+      <p:pic>
+        <p:nvPicPr>
+          <p:cNvPr id="2" name="slide-14.png"/>
+          <p:cNvPicPr/>
+          <p:nvPr/>
+        </p:nvPicPr>
+        <p:blipFill>
+          <a:blip r:embed="rId1"/>
+          <a:stretch>
+            <a:fillRect/>
+          </a:stretch>
+        </p:blipFill>
+        <p:spPr>
+          <a:xfrm>
+            <a:off x="0" y="0"/>
+            <a:ext cx="12192000" cy="6858000"/>
+          </a:xfrm>
+          <a:prstGeom prst="rect">
+            <a:avLst/>
+          </a:prstGeom>
+        </p:spPr>
+      </p:pic>
+    </p:spTree>
+  </p:cSld>
+  <p:clrMapOvr>
+    <a:masterClrMapping/>
+  </p:clrMapOvr>
+</p:sld>
+</file>
+
+<file path=ppt/slides/slide15.xml><?xml version="1.0" encoding="utf-8"?>
+<p:sld xmlns:a="http://schemas.openxmlformats.org/drawingml/2006/main" xmlns:r="http://schemas.openxmlformats.org/officeDocument/2006/relationships" xmlns:p="http://schemas.openxmlformats.org/presentationml/2006/main">
+  <p:cSld>
+    <p:spTree>
+      <p:nvGrpSpPr>
+        <p:cNvPr id="1" name=""/>
+        <p:cNvGrpSpPr/>
+        <p:nvPr/>
+      </p:nvGrpSpPr>
+      <p:grpSpPr>
+        <a:xfrm>
+          <a:off x="0" y="0"/>
+          <a:ext cx="0" cy="0"/>
+          <a:chOff x="0" y="0"/>
+          <a:chExt cx="0" cy="0"/>
+        </a:xfrm>
+      </p:grpSpPr>
+      <p:pic>
+        <p:nvPicPr>
+          <p:cNvPr id="2" name="slide-15.png"/>
+          <p:cNvPicPr/>
+          <p:nvPr/>
+        </p:nvPicPr>
+        <p:blipFill>
+          <a:blip r:embed="rId1"/>
           <a:stretch>
             <a:fillRect/>
           </a:stretch>
@@ -249,14 +430,12 @@
       </p:grpSpPr>
       <p:pic>
         <p:nvPicPr>
-          <p:cNvPr id="2" name="Slide 2 image"/>
-          <p:cNvPicPr>
-            <a:picLocks noChangeAspect="1"/>
-          </p:cNvPicPr>
-          <p:nvPr/>
-        </p:nvPicPr>
-        <p:blipFill>
-          <a:blip r:embed="rId2"/>
+          <p:cNvPr id="2" name="slide-2.png"/>
+          <p:cNvPicPr/>
+          <p:nvPr/>
+        </p:nvPicPr>
+        <p:blipFill>
+          <a:blip r:embed="rId1"/>
           <a:stretch>
             <a:fillRect/>
           </a:stretch>
@@ -298,14 +477,12 @@
       </p:grpSpPr>
       <p:pic>
         <p:nvPicPr>
-          <p:cNvPr id="2" name="Slide 3 image"/>
-          <p:cNvPicPr>
-            <a:picLocks noChangeAspect="1"/>
-          </p:cNvPicPr>
-          <p:nvPr/>
-        </p:nvPicPr>
-        <p:blipFill>
-          <a:blip r:embed="rId2"/>
+          <p:cNvPr id="2" name="slide-3.png"/>
+          <p:cNvPicPr/>
+          <p:nvPr/>
+        </p:nvPicPr>
+        <p:blipFill>
+          <a:blip r:embed="rId1"/>
           <a:stretch>
             <a:fillRect/>
           </a:stretch>
@@ -347,14 +524,12 @@
       </p:grpSpPr>
       <p:pic>
         <p:nvPicPr>
-          <p:cNvPr id="2" name="Slide 4 image"/>
-          <p:cNvPicPr>
-            <a:picLocks noChangeAspect="1"/>
-          </p:cNvPicPr>
-          <p:nvPr/>
-        </p:nvPicPr>
-        <p:blipFill>
-          <a:blip r:embed="rId2"/>
+          <p:cNvPr id="2" name="slide-4.png"/>
+          <p:cNvPicPr/>
+          <p:nvPr/>
+        </p:nvPicPr>
+        <p:blipFill>
+          <a:blip r:embed="rId1"/>
           <a:stretch>
             <a:fillRect/>
           </a:stretch>
@@ -396,14 +571,12 @@
       </p:grpSpPr>
       <p:pic>
         <p:nvPicPr>
-          <p:cNvPr id="2" name="Slide 5 image"/>
-          <p:cNvPicPr>
-            <a:picLocks noChangeAspect="1"/>
-          </p:cNvPicPr>
-          <p:nvPr/>
-        </p:nvPicPr>
-        <p:blipFill>
-          <a:blip r:embed="rId2"/>
+          <p:cNvPr id="2" name="slide-5.png"/>
+          <p:cNvPicPr/>
+          <p:nvPr/>
+        </p:nvPicPr>
+        <p:blipFill>
+          <a:blip r:embed="rId1"/>
           <a:stretch>
             <a:fillRect/>
           </a:stretch>
@@ -445,14 +618,12 @@
       </p:grpSpPr>
       <p:pic>
         <p:nvPicPr>
-          <p:cNvPr id="2" name="Slide 6 image"/>
-          <p:cNvPicPr>
-            <a:picLocks noChangeAspect="1"/>
-          </p:cNvPicPr>
-          <p:nvPr/>
-        </p:nvPicPr>
-        <p:blipFill>
-          <a:blip r:embed="rId2"/>
+          <p:cNvPr id="2" name="slide-6.png"/>
+          <p:cNvPicPr/>
+          <p:nvPr/>
+        </p:nvPicPr>
+        <p:blipFill>
+          <a:blip r:embed="rId1"/>
           <a:stretch>
             <a:fillRect/>
           </a:stretch>
@@ -494,14 +665,12 @@
       </p:grpSpPr>
       <p:pic>
         <p:nvPicPr>
-          <p:cNvPr id="2" name="Slide 7 image"/>
-          <p:cNvPicPr>
-            <a:picLocks noChangeAspect="1"/>
-          </p:cNvPicPr>
-          <p:nvPr/>
-        </p:nvPicPr>
-        <p:blipFill>
-          <a:blip r:embed="rId2"/>
+          <p:cNvPr id="2" name="slide-7.png"/>
+          <p:cNvPicPr/>
+          <p:nvPr/>
+        </p:nvPicPr>
+        <p:blipFill>
+          <a:blip r:embed="rId1"/>
           <a:stretch>
             <a:fillRect/>
           </a:stretch>
@@ -543,14 +712,12 @@
       </p:grpSpPr>
       <p:pic>
         <p:nvPicPr>
-          <p:cNvPr id="2" name="Slide 8 image"/>
-          <p:cNvPicPr>
-            <a:picLocks noChangeAspect="1"/>
-          </p:cNvPicPr>
-          <p:nvPr/>
-        </p:nvPicPr>
-        <p:blipFill>
-          <a:blip r:embed="rId2"/>
+          <p:cNvPr id="2" name="slide-8.png"/>
+          <p:cNvPicPr/>
+          <p:nvPr/>
+        </p:nvPicPr>
+        <p:blipFill>
+          <a:blip r:embed="rId1"/>
           <a:stretch>
             <a:fillRect/>
           </a:stretch>
@@ -592,14 +759,12 @@
       </p:grpSpPr>
       <p:pic>
         <p:nvPicPr>
-          <p:cNvPr id="2" name="Slide 9 image"/>
-          <p:cNvPicPr>
-            <a:picLocks noChangeAspect="1"/>
-          </p:cNvPicPr>
-          <p:nvPr/>
-        </p:nvPicPr>
-        <p:blipFill>
-          <a:blip r:embed="rId2"/>
+          <p:cNvPr id="2" name="slide-9.png"/>
+          <p:cNvPicPr/>
+          <p:nvPr/>
+        </p:nvPicPr>
+        <p:blipFill>
+          <a:blip r:embed="rId1"/>
           <a:stretch>
             <a:fillRect/>
           </a:stretch>

</xml_diff>